<commit_message>
pre class 2 update -  not final
</commit_message>
<xml_diff>
--- a/lectures/2026_GNET749_Lecture1.pptx
+++ b/lectures/2026_GNET749_Lecture1.pptx
@@ -227,7 +227,7 @@
           <a:p>
             <a:fld id="{C5FEF040-B39B-4340-BEB8-C7DA9E0F0E03}" type="datetimeFigureOut">
               <a:rPr lang="en-US" smtClean="0"/>
-              <a:t>4/15/26</a:t>
+              <a:t>4/20/26</a:t>
             </a:fld>
             <a:endParaRPr lang="en-US"/>
           </a:p>
@@ -714,7 +714,7 @@
           <a:p>
             <a:fld id="{528A02B3-B8F4-4E4C-BF34-8FF9203166F1}" type="datetimeFigureOut">
               <a:rPr lang="en-US" smtClean="0"/>
-              <a:t>4/15/26</a:t>
+              <a:t>4/20/26</a:t>
             </a:fld>
             <a:endParaRPr lang="en-US"/>
           </a:p>
@@ -912,7 +912,7 @@
           <a:p>
             <a:fld id="{528A02B3-B8F4-4E4C-BF34-8FF9203166F1}" type="datetimeFigureOut">
               <a:rPr lang="en-US" smtClean="0"/>
-              <a:t>4/15/26</a:t>
+              <a:t>4/20/26</a:t>
             </a:fld>
             <a:endParaRPr lang="en-US"/>
           </a:p>
@@ -1120,7 +1120,7 @@
           <a:p>
             <a:fld id="{528A02B3-B8F4-4E4C-BF34-8FF9203166F1}" type="datetimeFigureOut">
               <a:rPr lang="en-US" smtClean="0"/>
-              <a:t>4/15/26</a:t>
+              <a:t>4/20/26</a:t>
             </a:fld>
             <a:endParaRPr lang="en-US"/>
           </a:p>
@@ -1318,7 +1318,7 @@
           <a:p>
             <a:fld id="{528A02B3-B8F4-4E4C-BF34-8FF9203166F1}" type="datetimeFigureOut">
               <a:rPr lang="en-US" smtClean="0"/>
-              <a:t>4/15/26</a:t>
+              <a:t>4/20/26</a:t>
             </a:fld>
             <a:endParaRPr lang="en-US"/>
           </a:p>
@@ -1593,7 +1593,7 @@
           <a:p>
             <a:fld id="{528A02B3-B8F4-4E4C-BF34-8FF9203166F1}" type="datetimeFigureOut">
               <a:rPr lang="en-US" smtClean="0"/>
-              <a:t>4/15/26</a:t>
+              <a:t>4/20/26</a:t>
             </a:fld>
             <a:endParaRPr lang="en-US"/>
           </a:p>
@@ -1858,7 +1858,7 @@
           <a:p>
             <a:fld id="{528A02B3-B8F4-4E4C-BF34-8FF9203166F1}" type="datetimeFigureOut">
               <a:rPr lang="en-US" smtClean="0"/>
-              <a:t>4/15/26</a:t>
+              <a:t>4/20/26</a:t>
             </a:fld>
             <a:endParaRPr lang="en-US"/>
           </a:p>
@@ -2270,7 +2270,7 @@
           <a:p>
             <a:fld id="{528A02B3-B8F4-4E4C-BF34-8FF9203166F1}" type="datetimeFigureOut">
               <a:rPr lang="en-US" smtClean="0"/>
-              <a:t>4/15/26</a:t>
+              <a:t>4/20/26</a:t>
             </a:fld>
             <a:endParaRPr lang="en-US"/>
           </a:p>
@@ -2411,7 +2411,7 @@
           <a:p>
             <a:fld id="{528A02B3-B8F4-4E4C-BF34-8FF9203166F1}" type="datetimeFigureOut">
               <a:rPr lang="en-US" smtClean="0"/>
-              <a:t>4/15/26</a:t>
+              <a:t>4/20/26</a:t>
             </a:fld>
             <a:endParaRPr lang="en-US"/>
           </a:p>
@@ -2524,7 +2524,7 @@
           <a:p>
             <a:fld id="{528A02B3-B8F4-4E4C-BF34-8FF9203166F1}" type="datetimeFigureOut">
               <a:rPr lang="en-US" smtClean="0"/>
-              <a:t>4/15/26</a:t>
+              <a:t>4/20/26</a:t>
             </a:fld>
             <a:endParaRPr lang="en-US"/>
           </a:p>
@@ -2835,7 +2835,7 @@
           <a:p>
             <a:fld id="{528A02B3-B8F4-4E4C-BF34-8FF9203166F1}" type="datetimeFigureOut">
               <a:rPr lang="en-US" smtClean="0"/>
-              <a:t>4/15/26</a:t>
+              <a:t>4/20/26</a:t>
             </a:fld>
             <a:endParaRPr lang="en-US"/>
           </a:p>
@@ -3123,7 +3123,7 @@
           <a:p>
             <a:fld id="{528A02B3-B8F4-4E4C-BF34-8FF9203166F1}" type="datetimeFigureOut">
               <a:rPr lang="en-US" smtClean="0"/>
-              <a:t>4/15/26</a:t>
+              <a:t>4/20/26</a:t>
             </a:fld>
             <a:endParaRPr lang="en-US"/>
           </a:p>
@@ -3364,7 +3364,7 @@
           <a:p>
             <a:fld id="{528A02B3-B8F4-4E4C-BF34-8FF9203166F1}" type="datetimeFigureOut">
               <a:rPr lang="en-US" smtClean="0"/>
-              <a:t>4/15/26</a:t>
+              <a:t>4/20/26</a:t>
             </a:fld>
             <a:endParaRPr lang="en-US"/>
           </a:p>
@@ -3800,7 +3800,7 @@
           </a:ln>
           <a:extLst>
             <a:ext uri="{C572A759-6A51-4108-AA02-DFA0A04FC94B}">
-              <ma14:wrappingTextBoxFlag xmlns:ma14="http://schemas.microsoft.com/office/mac/drawingml/2011/main" xmlns:a14="http://schemas.microsoft.com/office/drawing/2010/main" xmlns:m="http://schemas.openxmlformats.org/officeDocument/2006/math" xmlns="" val="1"/>
+              <ma14:wrappingTextBoxFlag xmlns="" xmlns:m="http://schemas.openxmlformats.org/officeDocument/2006/math" xmlns:a14="http://schemas.microsoft.com/office/drawing/2010/main" xmlns:ma14="http://schemas.microsoft.com/office/mac/drawingml/2011/main" val="1"/>
             </a:ext>
           </a:extLst>
         </p:spPr>
@@ -4055,7 +4055,7 @@
           </a:ln>
           <a:extLst>
             <a:ext uri="{C572A759-6A51-4108-AA02-DFA0A04FC94B}">
-              <ma14:wrappingTextBoxFlag xmlns:ma14="http://schemas.microsoft.com/office/mac/drawingml/2011/main" xmlns:a14="http://schemas.microsoft.com/office/drawing/2010/main" xmlns:m="http://schemas.openxmlformats.org/officeDocument/2006/math" xmlns="" val="1"/>
+              <ma14:wrappingTextBoxFlag xmlns="" xmlns:m="http://schemas.openxmlformats.org/officeDocument/2006/math" xmlns:a14="http://schemas.microsoft.com/office/drawing/2010/main" xmlns:ma14="http://schemas.microsoft.com/office/mac/drawingml/2011/main" val="1"/>
             </a:ext>
           </a:extLst>
         </p:spPr>
@@ -4107,7 +4107,7 @@
           </a:ln>
           <a:extLst>
             <a:ext uri="{C572A759-6A51-4108-AA02-DFA0A04FC94B}">
-              <ma14:wrappingTextBoxFlag xmlns:ma14="http://schemas.microsoft.com/office/mac/drawingml/2011/main" xmlns:a14="http://schemas.microsoft.com/office/drawing/2010/main" xmlns:m="http://schemas.openxmlformats.org/officeDocument/2006/math" xmlns="" val="1"/>
+              <ma14:wrappingTextBoxFlag xmlns="" xmlns:m="http://schemas.openxmlformats.org/officeDocument/2006/math" xmlns:a14="http://schemas.microsoft.com/office/drawing/2010/main" xmlns:ma14="http://schemas.microsoft.com/office/mac/drawingml/2011/main" val="1"/>
             </a:ext>
           </a:extLst>
         </p:spPr>
@@ -4229,7 +4229,7 @@
           </a:ln>
           <a:extLst>
             <a:ext uri="{C572A759-6A51-4108-AA02-DFA0A04FC94B}">
-              <ma14:wrappingTextBoxFlag xmlns:ma14="http://schemas.microsoft.com/office/mac/drawingml/2011/main" xmlns:a14="http://schemas.microsoft.com/office/drawing/2010/main" xmlns:m="http://schemas.openxmlformats.org/officeDocument/2006/math" xmlns="" val="1"/>
+              <ma14:wrappingTextBoxFlag xmlns="" xmlns:m="http://schemas.openxmlformats.org/officeDocument/2006/math" xmlns:a14="http://schemas.microsoft.com/office/drawing/2010/main" xmlns:ma14="http://schemas.microsoft.com/office/mac/drawingml/2011/main" val="1"/>
             </a:ext>
           </a:extLst>
         </p:spPr>
@@ -4269,7 +4269,7 @@
           </a:ln>
           <a:extLst>
             <a:ext uri="{C572A759-6A51-4108-AA02-DFA0A04FC94B}">
-              <ma14:wrappingTextBoxFlag xmlns:ma14="http://schemas.microsoft.com/office/mac/drawingml/2011/main" xmlns:a14="http://schemas.microsoft.com/office/drawing/2010/main" xmlns:m="http://schemas.openxmlformats.org/officeDocument/2006/math" xmlns="" val="1"/>
+              <ma14:wrappingTextBoxFlag xmlns="" xmlns:m="http://schemas.openxmlformats.org/officeDocument/2006/math" xmlns:a14="http://schemas.microsoft.com/office/drawing/2010/main" xmlns:ma14="http://schemas.microsoft.com/office/mac/drawingml/2011/main" val="1"/>
             </a:ext>
           </a:extLst>
         </p:spPr>
@@ -4656,7 +4656,7 @@
           </a:ln>
           <a:extLst>
             <a:ext uri="{C572A759-6A51-4108-AA02-DFA0A04FC94B}">
-              <ma14:wrappingTextBoxFlag xmlns:ma14="http://schemas.microsoft.com/office/mac/drawingml/2011/main" xmlns:a14="http://schemas.microsoft.com/office/drawing/2010/main" xmlns:m="http://schemas.openxmlformats.org/officeDocument/2006/math" xmlns="" val="1"/>
+              <ma14:wrappingTextBoxFlag xmlns="" xmlns:m="http://schemas.openxmlformats.org/officeDocument/2006/math" xmlns:a14="http://schemas.microsoft.com/office/drawing/2010/main" xmlns:ma14="http://schemas.microsoft.com/office/mac/drawingml/2011/main" val="1"/>
             </a:ext>
           </a:extLst>
         </p:spPr>
@@ -4701,7 +4701,7 @@
           </a:ln>
           <a:extLst>
             <a:ext uri="{C572A759-6A51-4108-AA02-DFA0A04FC94B}">
-              <ma14:wrappingTextBoxFlag xmlns:ma14="http://schemas.microsoft.com/office/mac/drawingml/2011/main" xmlns:a14="http://schemas.microsoft.com/office/drawing/2010/main" xmlns:m="http://schemas.openxmlformats.org/officeDocument/2006/math" xmlns="" val="1"/>
+              <ma14:wrappingTextBoxFlag xmlns="" xmlns:m="http://schemas.openxmlformats.org/officeDocument/2006/math" xmlns:a14="http://schemas.microsoft.com/office/drawing/2010/main" xmlns:ma14="http://schemas.microsoft.com/office/mac/drawingml/2011/main" val="1"/>
             </a:ext>
           </a:extLst>
         </p:spPr>
@@ -4910,7 +4910,7 @@
           </a:ln>
           <a:extLst>
             <a:ext uri="{C572A759-6A51-4108-AA02-DFA0A04FC94B}">
-              <ma14:wrappingTextBoxFlag xmlns:ma14="http://schemas.microsoft.com/office/mac/drawingml/2011/main" xmlns:a14="http://schemas.microsoft.com/office/drawing/2010/main" xmlns:m="http://schemas.openxmlformats.org/officeDocument/2006/math" xmlns="" val="1"/>
+              <ma14:wrappingTextBoxFlag xmlns="" xmlns:m="http://schemas.openxmlformats.org/officeDocument/2006/math" xmlns:a14="http://schemas.microsoft.com/office/drawing/2010/main" xmlns:ma14="http://schemas.microsoft.com/office/mac/drawingml/2011/main" val="1"/>
             </a:ext>
           </a:extLst>
         </p:spPr>
@@ -4955,7 +4955,7 @@
           </a:ln>
           <a:extLst>
             <a:ext uri="{C572A759-6A51-4108-AA02-DFA0A04FC94B}">
-              <ma14:wrappingTextBoxFlag xmlns:ma14="http://schemas.microsoft.com/office/mac/drawingml/2011/main" xmlns:a14="http://schemas.microsoft.com/office/drawing/2010/main" xmlns:m="http://schemas.openxmlformats.org/officeDocument/2006/math" xmlns="" val="1"/>
+              <ma14:wrappingTextBoxFlag xmlns="" xmlns:m="http://schemas.openxmlformats.org/officeDocument/2006/math" xmlns:a14="http://schemas.microsoft.com/office/drawing/2010/main" xmlns:ma14="http://schemas.microsoft.com/office/mac/drawingml/2011/main" val="1"/>
             </a:ext>
           </a:extLst>
         </p:spPr>
@@ -5094,7 +5094,7 @@
           </a:ln>
           <a:extLst>
             <a:ext uri="{C572A759-6A51-4108-AA02-DFA0A04FC94B}">
-              <ma14:wrappingTextBoxFlag xmlns:ma14="http://schemas.microsoft.com/office/mac/drawingml/2011/main" xmlns:a14="http://schemas.microsoft.com/office/drawing/2010/main" xmlns:m="http://schemas.openxmlformats.org/officeDocument/2006/math" xmlns="" val="1"/>
+              <ma14:wrappingTextBoxFlag xmlns="" xmlns:m="http://schemas.openxmlformats.org/officeDocument/2006/math" xmlns:a14="http://schemas.microsoft.com/office/drawing/2010/main" xmlns:ma14="http://schemas.microsoft.com/office/mac/drawingml/2011/main" val="1"/>
             </a:ext>
           </a:extLst>
         </p:spPr>
@@ -5134,7 +5134,7 @@
           </a:ln>
           <a:extLst>
             <a:ext uri="{C572A759-6A51-4108-AA02-DFA0A04FC94B}">
-              <ma14:wrappingTextBoxFlag xmlns:ma14="http://schemas.microsoft.com/office/mac/drawingml/2011/main" xmlns:a14="http://schemas.microsoft.com/office/drawing/2010/main" xmlns:m="http://schemas.openxmlformats.org/officeDocument/2006/math" xmlns="" val="1"/>
+              <ma14:wrappingTextBoxFlag xmlns="" xmlns:m="http://schemas.openxmlformats.org/officeDocument/2006/math" xmlns:a14="http://schemas.microsoft.com/office/drawing/2010/main" xmlns:ma14="http://schemas.microsoft.com/office/mac/drawingml/2011/main" val="1"/>
             </a:ext>
           </a:extLst>
         </p:spPr>
@@ -5206,7 +5206,7 @@
           </a:ln>
           <a:extLst>
             <a:ext uri="{C572A759-6A51-4108-AA02-DFA0A04FC94B}">
-              <ma14:wrappingTextBoxFlag xmlns:ma14="http://schemas.microsoft.com/office/mac/drawingml/2011/main" xmlns:a14="http://schemas.microsoft.com/office/drawing/2010/main" xmlns:m="http://schemas.openxmlformats.org/officeDocument/2006/math" xmlns="" val="1"/>
+              <ma14:wrappingTextBoxFlag xmlns="" xmlns:m="http://schemas.openxmlformats.org/officeDocument/2006/math" xmlns:a14="http://schemas.microsoft.com/office/drawing/2010/main" xmlns:ma14="http://schemas.microsoft.com/office/mac/drawingml/2011/main" val="1"/>
             </a:ext>
           </a:extLst>
         </p:spPr>
@@ -5255,7 +5255,7 @@
           </a:ln>
           <a:extLst>
             <a:ext uri="{C572A759-6A51-4108-AA02-DFA0A04FC94B}">
-              <ma14:wrappingTextBoxFlag xmlns:ma14="http://schemas.microsoft.com/office/mac/drawingml/2011/main" xmlns:a14="http://schemas.microsoft.com/office/drawing/2010/main" xmlns:m="http://schemas.openxmlformats.org/officeDocument/2006/math" xmlns="" val="1"/>
+              <ma14:wrappingTextBoxFlag xmlns="" xmlns:m="http://schemas.openxmlformats.org/officeDocument/2006/math" xmlns:a14="http://schemas.microsoft.com/office/drawing/2010/main" xmlns:ma14="http://schemas.microsoft.com/office/mac/drawingml/2011/main" val="1"/>
             </a:ext>
           </a:extLst>
         </p:spPr>
@@ -5316,7 +5316,7 @@
           </a:ln>
           <a:extLst>
             <a:ext uri="{C572A759-6A51-4108-AA02-DFA0A04FC94B}">
-              <ma14:wrappingTextBoxFlag xmlns:ma14="http://schemas.microsoft.com/office/mac/drawingml/2011/main" xmlns:a14="http://schemas.microsoft.com/office/drawing/2010/main" xmlns:m="http://schemas.openxmlformats.org/officeDocument/2006/math" xmlns="" val="1"/>
+              <ma14:wrappingTextBoxFlag xmlns="" xmlns:m="http://schemas.openxmlformats.org/officeDocument/2006/math" xmlns:a14="http://schemas.microsoft.com/office/drawing/2010/main" xmlns:ma14="http://schemas.microsoft.com/office/mac/drawingml/2011/main" val="1"/>
             </a:ext>
           </a:extLst>
         </p:spPr>
@@ -5356,7 +5356,7 @@
           </a:ln>
           <a:extLst>
             <a:ext uri="{C572A759-6A51-4108-AA02-DFA0A04FC94B}">
-              <ma14:wrappingTextBoxFlag xmlns:ma14="http://schemas.microsoft.com/office/mac/drawingml/2011/main" xmlns:a14="http://schemas.microsoft.com/office/drawing/2010/main" xmlns:m="http://schemas.openxmlformats.org/officeDocument/2006/math" xmlns="" val="1"/>
+              <ma14:wrappingTextBoxFlag xmlns="" xmlns:m="http://schemas.openxmlformats.org/officeDocument/2006/math" xmlns:a14="http://schemas.microsoft.com/office/drawing/2010/main" xmlns:ma14="http://schemas.microsoft.com/office/mac/drawingml/2011/main" val="1"/>
             </a:ext>
           </a:extLst>
         </p:spPr>
@@ -5396,7 +5396,7 @@
           </a:ln>
           <a:extLst>
             <a:ext uri="{C572A759-6A51-4108-AA02-DFA0A04FC94B}">
-              <ma14:wrappingTextBoxFlag xmlns:ma14="http://schemas.microsoft.com/office/mac/drawingml/2011/main" xmlns:a14="http://schemas.microsoft.com/office/drawing/2010/main" xmlns:m="http://schemas.openxmlformats.org/officeDocument/2006/math" xmlns="" val="1"/>
+              <ma14:wrappingTextBoxFlag xmlns="" xmlns:m="http://schemas.openxmlformats.org/officeDocument/2006/math" xmlns:a14="http://schemas.microsoft.com/office/drawing/2010/main" xmlns:ma14="http://schemas.microsoft.com/office/mac/drawingml/2011/main" val="1"/>
             </a:ext>
           </a:extLst>
         </p:spPr>
@@ -5436,7 +5436,7 @@
           </a:ln>
           <a:extLst>
             <a:ext uri="{C572A759-6A51-4108-AA02-DFA0A04FC94B}">
-              <ma14:wrappingTextBoxFlag xmlns:ma14="http://schemas.microsoft.com/office/mac/drawingml/2011/main" xmlns:a14="http://schemas.microsoft.com/office/drawing/2010/main" xmlns:m="http://schemas.openxmlformats.org/officeDocument/2006/math" xmlns="" val="1"/>
+              <ma14:wrappingTextBoxFlag xmlns="" xmlns:m="http://schemas.openxmlformats.org/officeDocument/2006/math" xmlns:a14="http://schemas.microsoft.com/office/drawing/2010/main" xmlns:ma14="http://schemas.microsoft.com/office/mac/drawingml/2011/main" val="1"/>
             </a:ext>
           </a:extLst>
         </p:spPr>
@@ -5476,7 +5476,7 @@
           </a:ln>
           <a:extLst>
             <a:ext uri="{C572A759-6A51-4108-AA02-DFA0A04FC94B}">
-              <ma14:wrappingTextBoxFlag xmlns:ma14="http://schemas.microsoft.com/office/mac/drawingml/2011/main" xmlns:a14="http://schemas.microsoft.com/office/drawing/2010/main" xmlns:m="http://schemas.openxmlformats.org/officeDocument/2006/math" xmlns="" val="1"/>
+              <ma14:wrappingTextBoxFlag xmlns="" xmlns:m="http://schemas.openxmlformats.org/officeDocument/2006/math" xmlns:a14="http://schemas.microsoft.com/office/drawing/2010/main" xmlns:ma14="http://schemas.microsoft.com/office/mac/drawingml/2011/main" val="1"/>
             </a:ext>
           </a:extLst>
         </p:spPr>
@@ -5631,7 +5631,7 @@
           </a:ln>
           <a:extLst>
             <a:ext uri="{C572A759-6A51-4108-AA02-DFA0A04FC94B}">
-              <ma14:wrappingTextBoxFlag xmlns:ma14="http://schemas.microsoft.com/office/mac/drawingml/2011/main" xmlns:a14="http://schemas.microsoft.com/office/drawing/2010/main" xmlns:m="http://schemas.openxmlformats.org/officeDocument/2006/math" xmlns="" val="1"/>
+              <ma14:wrappingTextBoxFlag xmlns="" xmlns:m="http://schemas.openxmlformats.org/officeDocument/2006/math" xmlns:a14="http://schemas.microsoft.com/office/drawing/2010/main" xmlns:ma14="http://schemas.microsoft.com/office/mac/drawingml/2011/main" val="1"/>
             </a:ext>
           </a:extLst>
         </p:spPr>
@@ -5671,7 +5671,7 @@
           </a:ln>
           <a:extLst>
             <a:ext uri="{C572A759-6A51-4108-AA02-DFA0A04FC94B}">
-              <ma14:wrappingTextBoxFlag xmlns:ma14="http://schemas.microsoft.com/office/mac/drawingml/2011/main" xmlns:a14="http://schemas.microsoft.com/office/drawing/2010/main" xmlns:m="http://schemas.openxmlformats.org/officeDocument/2006/math" xmlns="" val="1"/>
+              <ma14:wrappingTextBoxFlag xmlns="" xmlns:m="http://schemas.openxmlformats.org/officeDocument/2006/math" xmlns:a14="http://schemas.microsoft.com/office/drawing/2010/main" xmlns:ma14="http://schemas.microsoft.com/office/mac/drawingml/2011/main" val="1"/>
             </a:ext>
           </a:extLst>
         </p:spPr>
@@ -5711,7 +5711,7 @@
           </a:ln>
           <a:extLst>
             <a:ext uri="{C572A759-6A51-4108-AA02-DFA0A04FC94B}">
-              <ma14:wrappingTextBoxFlag xmlns:ma14="http://schemas.microsoft.com/office/mac/drawingml/2011/main" xmlns:a14="http://schemas.microsoft.com/office/drawing/2010/main" xmlns:m="http://schemas.openxmlformats.org/officeDocument/2006/math" xmlns="" val="1"/>
+              <ma14:wrappingTextBoxFlag xmlns="" xmlns:m="http://schemas.openxmlformats.org/officeDocument/2006/math" xmlns:a14="http://schemas.microsoft.com/office/drawing/2010/main" xmlns:ma14="http://schemas.microsoft.com/office/mac/drawingml/2011/main" val="1"/>
             </a:ext>
           </a:extLst>
         </p:spPr>
@@ -5751,7 +5751,7 @@
           </a:ln>
           <a:extLst>
             <a:ext uri="{C572A759-6A51-4108-AA02-DFA0A04FC94B}">
-              <ma14:wrappingTextBoxFlag xmlns:ma14="http://schemas.microsoft.com/office/mac/drawingml/2011/main" xmlns:a14="http://schemas.microsoft.com/office/drawing/2010/main" xmlns:m="http://schemas.openxmlformats.org/officeDocument/2006/math" xmlns="" val="1"/>
+              <ma14:wrappingTextBoxFlag xmlns="" xmlns:m="http://schemas.openxmlformats.org/officeDocument/2006/math" xmlns:a14="http://schemas.microsoft.com/office/drawing/2010/main" xmlns:ma14="http://schemas.microsoft.com/office/mac/drawingml/2011/main" val="1"/>
             </a:ext>
           </a:extLst>
         </p:spPr>
@@ -5791,7 +5791,7 @@
           </a:ln>
           <a:extLst>
             <a:ext uri="{C572A759-6A51-4108-AA02-DFA0A04FC94B}">
-              <ma14:wrappingTextBoxFlag xmlns:ma14="http://schemas.microsoft.com/office/mac/drawingml/2011/main" xmlns:a14="http://schemas.microsoft.com/office/drawing/2010/main" xmlns:m="http://schemas.openxmlformats.org/officeDocument/2006/math" xmlns="" val="1"/>
+              <ma14:wrappingTextBoxFlag xmlns="" xmlns:m="http://schemas.openxmlformats.org/officeDocument/2006/math" xmlns:a14="http://schemas.microsoft.com/office/drawing/2010/main" xmlns:ma14="http://schemas.microsoft.com/office/mac/drawingml/2011/main" val="1"/>
             </a:ext>
           </a:extLst>
         </p:spPr>
@@ -5831,7 +5831,7 @@
           </a:ln>
           <a:extLst>
             <a:ext uri="{C572A759-6A51-4108-AA02-DFA0A04FC94B}">
-              <ma14:wrappingTextBoxFlag xmlns:ma14="http://schemas.microsoft.com/office/mac/drawingml/2011/main" xmlns:a14="http://schemas.microsoft.com/office/drawing/2010/main" xmlns:m="http://schemas.openxmlformats.org/officeDocument/2006/math" xmlns="" val="1"/>
+              <ma14:wrappingTextBoxFlag xmlns="" xmlns:m="http://schemas.openxmlformats.org/officeDocument/2006/math" xmlns:a14="http://schemas.microsoft.com/office/drawing/2010/main" xmlns:ma14="http://schemas.microsoft.com/office/mac/drawingml/2011/main" val="1"/>
             </a:ext>
           </a:extLst>
         </p:spPr>
@@ -5871,7 +5871,7 @@
           </a:ln>
           <a:extLst>
             <a:ext uri="{C572A759-6A51-4108-AA02-DFA0A04FC94B}">
-              <ma14:wrappingTextBoxFlag xmlns:ma14="http://schemas.microsoft.com/office/mac/drawingml/2011/main" xmlns:a14="http://schemas.microsoft.com/office/drawing/2010/main" xmlns:m="http://schemas.openxmlformats.org/officeDocument/2006/math" xmlns="" val="1"/>
+              <ma14:wrappingTextBoxFlag xmlns="" xmlns:m="http://schemas.openxmlformats.org/officeDocument/2006/math" xmlns:a14="http://schemas.microsoft.com/office/drawing/2010/main" xmlns:ma14="http://schemas.microsoft.com/office/mac/drawingml/2011/main" val="1"/>
             </a:ext>
           </a:extLst>
         </p:spPr>
@@ -5911,7 +5911,7 @@
           </a:ln>
           <a:extLst>
             <a:ext uri="{C572A759-6A51-4108-AA02-DFA0A04FC94B}">
-              <ma14:wrappingTextBoxFlag xmlns:ma14="http://schemas.microsoft.com/office/mac/drawingml/2011/main" xmlns:a14="http://schemas.microsoft.com/office/drawing/2010/main" xmlns:m="http://schemas.openxmlformats.org/officeDocument/2006/math" xmlns="" val="1"/>
+              <ma14:wrappingTextBoxFlag xmlns="" xmlns:m="http://schemas.openxmlformats.org/officeDocument/2006/math" xmlns:a14="http://schemas.microsoft.com/office/drawing/2010/main" xmlns:ma14="http://schemas.microsoft.com/office/mac/drawingml/2011/main" val="1"/>
             </a:ext>
           </a:extLst>
         </p:spPr>
@@ -5951,7 +5951,7 @@
           </a:ln>
           <a:extLst>
             <a:ext uri="{C572A759-6A51-4108-AA02-DFA0A04FC94B}">
-              <ma14:wrappingTextBoxFlag xmlns:ma14="http://schemas.microsoft.com/office/mac/drawingml/2011/main" xmlns:a14="http://schemas.microsoft.com/office/drawing/2010/main" xmlns:m="http://schemas.openxmlformats.org/officeDocument/2006/math" xmlns="" val="1"/>
+              <ma14:wrappingTextBoxFlag xmlns="" xmlns:m="http://schemas.openxmlformats.org/officeDocument/2006/math" xmlns:a14="http://schemas.microsoft.com/office/drawing/2010/main" xmlns:ma14="http://schemas.microsoft.com/office/mac/drawingml/2011/main" val="1"/>
             </a:ext>
           </a:extLst>
         </p:spPr>
@@ -6036,7 +6036,7 @@
           </a:ln>
           <a:extLst>
             <a:ext uri="{C572A759-6A51-4108-AA02-DFA0A04FC94B}">
-              <ma14:wrappingTextBoxFlag xmlns:ma14="http://schemas.microsoft.com/office/mac/drawingml/2011/main" xmlns:a14="http://schemas.microsoft.com/office/drawing/2010/main" xmlns:m="http://schemas.openxmlformats.org/officeDocument/2006/math" xmlns="" val="1"/>
+              <ma14:wrappingTextBoxFlag xmlns="" xmlns:m="http://schemas.openxmlformats.org/officeDocument/2006/math" xmlns:a14="http://schemas.microsoft.com/office/drawing/2010/main" xmlns:ma14="http://schemas.microsoft.com/office/mac/drawingml/2011/main" val="1"/>
             </a:ext>
           </a:extLst>
         </p:spPr>
@@ -6076,7 +6076,7 @@
           </a:ln>
           <a:extLst>
             <a:ext uri="{C572A759-6A51-4108-AA02-DFA0A04FC94B}">
-              <ma14:wrappingTextBoxFlag xmlns:ma14="http://schemas.microsoft.com/office/mac/drawingml/2011/main" xmlns:a14="http://schemas.microsoft.com/office/drawing/2010/main" xmlns:m="http://schemas.openxmlformats.org/officeDocument/2006/math" xmlns="" val="1"/>
+              <ma14:wrappingTextBoxFlag xmlns="" xmlns:m="http://schemas.openxmlformats.org/officeDocument/2006/math" xmlns:a14="http://schemas.microsoft.com/office/drawing/2010/main" xmlns:ma14="http://schemas.microsoft.com/office/mac/drawingml/2011/main" val="1"/>
             </a:ext>
           </a:extLst>
         </p:spPr>
@@ -6346,7 +6346,7 @@
           </a:ln>
           <a:extLst>
             <a:ext uri="{C572A759-6A51-4108-AA02-DFA0A04FC94B}">
-              <ma14:wrappingTextBoxFlag xmlns="" xmlns:m="http://schemas.openxmlformats.org/officeDocument/2006/math" xmlns:a14="http://schemas.microsoft.com/office/drawing/2010/main" xmlns:ma14="http://schemas.microsoft.com/office/mac/drawingml/2011/main" val="1"/>
+              <ma14:wrappingTextBoxFlag xmlns:ma14="http://schemas.microsoft.com/office/mac/drawingml/2011/main" xmlns:a14="http://schemas.microsoft.com/office/drawing/2010/main" xmlns:m="http://schemas.openxmlformats.org/officeDocument/2006/math" xmlns="" val="1"/>
             </a:ext>
           </a:extLst>
         </p:spPr>
@@ -6397,7 +6397,7 @@
           </a:ln>
           <a:extLst>
             <a:ext uri="{C572A759-6A51-4108-AA02-DFA0A04FC94B}">
-              <ma14:wrappingTextBoxFlag xmlns="" xmlns:m="http://schemas.openxmlformats.org/officeDocument/2006/math" xmlns:a14="http://schemas.microsoft.com/office/drawing/2010/main" xmlns:ma14="http://schemas.microsoft.com/office/mac/drawingml/2011/main" val="1"/>
+              <ma14:wrappingTextBoxFlag xmlns:ma14="http://schemas.microsoft.com/office/mac/drawingml/2011/main" xmlns:a14="http://schemas.microsoft.com/office/drawing/2010/main" xmlns:m="http://schemas.openxmlformats.org/officeDocument/2006/math" xmlns="" val="1"/>
             </a:ext>
           </a:extLst>
         </p:spPr>
@@ -6551,7 +6551,7 @@
           </a:ln>
           <a:extLst>
             <a:ext uri="{C572A759-6A51-4108-AA02-DFA0A04FC94B}">
-              <ma14:wrappingTextBoxFlag xmlns="" xmlns:m="http://schemas.openxmlformats.org/officeDocument/2006/math" xmlns:a14="http://schemas.microsoft.com/office/drawing/2010/main" xmlns:ma14="http://schemas.microsoft.com/office/mac/drawingml/2011/main" val="1"/>
+              <ma14:wrappingTextBoxFlag xmlns:ma14="http://schemas.microsoft.com/office/mac/drawingml/2011/main" xmlns:a14="http://schemas.microsoft.com/office/drawing/2010/main" xmlns:m="http://schemas.openxmlformats.org/officeDocument/2006/math" xmlns="" val="1"/>
             </a:ext>
           </a:extLst>
         </p:spPr>
@@ -6588,7 +6588,7 @@
           </a:ln>
           <a:extLst>
             <a:ext uri="{C572A759-6A51-4108-AA02-DFA0A04FC94B}">
-              <ma14:wrappingTextBoxFlag xmlns="" xmlns:m="http://schemas.openxmlformats.org/officeDocument/2006/math" xmlns:a14="http://schemas.microsoft.com/office/drawing/2010/main" xmlns:ma14="http://schemas.microsoft.com/office/mac/drawingml/2011/main" val="1"/>
+              <ma14:wrappingTextBoxFlag xmlns:ma14="http://schemas.microsoft.com/office/mac/drawingml/2011/main" xmlns:a14="http://schemas.microsoft.com/office/drawing/2010/main" xmlns:m="http://schemas.openxmlformats.org/officeDocument/2006/math" xmlns="" val="1"/>
             </a:ext>
           </a:extLst>
         </p:spPr>
@@ -6801,7 +6801,7 @@
           </a:ln>
           <a:extLst>
             <a:ext uri="{C572A759-6A51-4108-AA02-DFA0A04FC94B}">
-              <ma14:wrappingTextBoxFlag xmlns:ma14="http://schemas.microsoft.com/office/mac/drawingml/2011/main" xmlns:a14="http://schemas.microsoft.com/office/drawing/2010/main" xmlns:m="http://schemas.openxmlformats.org/officeDocument/2006/math" xmlns="" val="1"/>
+              <ma14:wrappingTextBoxFlag xmlns="" xmlns:m="http://schemas.openxmlformats.org/officeDocument/2006/math" xmlns:a14="http://schemas.microsoft.com/office/drawing/2010/main" xmlns:ma14="http://schemas.microsoft.com/office/mac/drawingml/2011/main" val="1"/>
             </a:ext>
           </a:extLst>
         </p:spPr>
@@ -6949,7 +6949,7 @@
           </a:ln>
           <a:extLst>
             <a:ext uri="{C572A759-6A51-4108-AA02-DFA0A04FC94B}">
-              <ma14:wrappingTextBoxFlag xmlns:ma14="http://schemas.microsoft.com/office/mac/drawingml/2011/main" xmlns:a14="http://schemas.microsoft.com/office/drawing/2010/main" xmlns:m="http://schemas.openxmlformats.org/officeDocument/2006/math" xmlns="" val="1"/>
+              <ma14:wrappingTextBoxFlag xmlns="" xmlns:m="http://schemas.openxmlformats.org/officeDocument/2006/math" xmlns:a14="http://schemas.microsoft.com/office/drawing/2010/main" xmlns:ma14="http://schemas.microsoft.com/office/mac/drawingml/2011/main" val="1"/>
             </a:ext>
           </a:extLst>
         </p:spPr>
@@ -6989,7 +6989,7 @@
           </a:ln>
           <a:extLst>
             <a:ext uri="{C572A759-6A51-4108-AA02-DFA0A04FC94B}">
-              <ma14:wrappingTextBoxFlag xmlns:ma14="http://schemas.microsoft.com/office/mac/drawingml/2011/main" xmlns:a14="http://schemas.microsoft.com/office/drawing/2010/main" xmlns:m="http://schemas.openxmlformats.org/officeDocument/2006/math" xmlns="" val="1"/>
+              <ma14:wrappingTextBoxFlag xmlns="" xmlns:m="http://schemas.openxmlformats.org/officeDocument/2006/math" xmlns:a14="http://schemas.microsoft.com/office/drawing/2010/main" xmlns:ma14="http://schemas.microsoft.com/office/mac/drawingml/2011/main" val="1"/>
             </a:ext>
           </a:extLst>
         </p:spPr>
@@ -7083,7 +7083,7 @@
           </a:ln>
           <a:extLst>
             <a:ext uri="{C572A759-6A51-4108-AA02-DFA0A04FC94B}">
-              <ma14:wrappingTextBoxFlag xmlns:ma14="http://schemas.microsoft.com/office/mac/drawingml/2011/main" xmlns:a14="http://schemas.microsoft.com/office/drawing/2010/main" xmlns:m="http://schemas.openxmlformats.org/officeDocument/2006/math" xmlns="" val="1"/>
+              <ma14:wrappingTextBoxFlag xmlns="" xmlns:m="http://schemas.openxmlformats.org/officeDocument/2006/math" xmlns:a14="http://schemas.microsoft.com/office/drawing/2010/main" xmlns:ma14="http://schemas.microsoft.com/office/mac/drawingml/2011/main" val="1"/>
             </a:ext>
           </a:extLst>
         </p:spPr>
@@ -7156,7 +7156,7 @@
           </a:ln>
           <a:extLst>
             <a:ext uri="{C572A759-6A51-4108-AA02-DFA0A04FC94B}">
-              <ma14:wrappingTextBoxFlag xmlns="" xmlns:m="http://schemas.openxmlformats.org/officeDocument/2006/math" xmlns:a14="http://schemas.microsoft.com/office/drawing/2010/main" xmlns:ma14="http://schemas.microsoft.com/office/mac/drawingml/2011/main" val="1"/>
+              <ma14:wrappingTextBoxFlag xmlns:ma14="http://schemas.microsoft.com/office/mac/drawingml/2011/main" xmlns:a14="http://schemas.microsoft.com/office/drawing/2010/main" xmlns:m="http://schemas.openxmlformats.org/officeDocument/2006/math" xmlns="" val="1"/>
             </a:ext>
           </a:extLst>
         </p:spPr>
@@ -7334,7 +7334,7 @@
           </a:ln>
           <a:extLst>
             <a:ext uri="{C572A759-6A51-4108-AA02-DFA0A04FC94B}">
-              <ma14:wrappingTextBoxFlag xmlns="" xmlns:m="http://schemas.openxmlformats.org/officeDocument/2006/math" xmlns:a14="http://schemas.microsoft.com/office/drawing/2010/main" xmlns:ma14="http://schemas.microsoft.com/office/mac/drawingml/2011/main" val="1"/>
+              <ma14:wrappingTextBoxFlag xmlns:ma14="http://schemas.microsoft.com/office/mac/drawingml/2011/main" xmlns:a14="http://schemas.microsoft.com/office/drawing/2010/main" xmlns:m="http://schemas.openxmlformats.org/officeDocument/2006/math" xmlns="" val="1"/>
             </a:ext>
           </a:extLst>
         </p:spPr>
@@ -7380,7 +7380,7 @@
           </a:ln>
           <a:extLst>
             <a:ext uri="{C572A759-6A51-4108-AA02-DFA0A04FC94B}">
-              <ma14:wrappingTextBoxFlag xmlns="" xmlns:m="http://schemas.openxmlformats.org/officeDocument/2006/math" xmlns:a14="http://schemas.microsoft.com/office/drawing/2010/main" xmlns:ma14="http://schemas.microsoft.com/office/mac/drawingml/2011/main" val="1"/>
+              <ma14:wrappingTextBoxFlag xmlns:ma14="http://schemas.microsoft.com/office/mac/drawingml/2011/main" xmlns:a14="http://schemas.microsoft.com/office/drawing/2010/main" xmlns:m="http://schemas.openxmlformats.org/officeDocument/2006/math" xmlns="" val="1"/>
             </a:ext>
           </a:extLst>
         </p:spPr>
@@ -7492,7 +7492,7 @@
           </a:ln>
           <a:extLst>
             <a:ext uri="{C572A759-6A51-4108-AA02-DFA0A04FC94B}">
-              <ma14:wrappingTextBoxFlag xmlns="" xmlns:m="http://schemas.openxmlformats.org/officeDocument/2006/math" xmlns:a14="http://schemas.microsoft.com/office/drawing/2010/main" xmlns:ma14="http://schemas.microsoft.com/office/mac/drawingml/2011/main" val="1"/>
+              <ma14:wrappingTextBoxFlag xmlns:ma14="http://schemas.microsoft.com/office/mac/drawingml/2011/main" xmlns:a14="http://schemas.microsoft.com/office/drawing/2010/main" xmlns:m="http://schemas.openxmlformats.org/officeDocument/2006/math" xmlns="" val="1"/>
             </a:ext>
           </a:extLst>
         </p:spPr>
@@ -7558,7 +7558,7 @@
           </a:ln>
           <a:extLst>
             <a:ext uri="{C572A759-6A51-4108-AA02-DFA0A04FC94B}">
-              <ma14:wrappingTextBoxFlag xmlns:ma14="http://schemas.microsoft.com/office/mac/drawingml/2011/main" xmlns:a14="http://schemas.microsoft.com/office/drawing/2010/main" xmlns:m="http://schemas.openxmlformats.org/officeDocument/2006/math" xmlns="" val="1"/>
+              <ma14:wrappingTextBoxFlag xmlns="" xmlns:m="http://schemas.openxmlformats.org/officeDocument/2006/math" xmlns:a14="http://schemas.microsoft.com/office/drawing/2010/main" xmlns:ma14="http://schemas.microsoft.com/office/mac/drawingml/2011/main" val="1"/>
             </a:ext>
           </a:extLst>
         </p:spPr>
@@ -7625,7 +7625,7 @@
           </a:ln>
           <a:extLst>
             <a:ext uri="{C572A759-6A51-4108-AA02-DFA0A04FC94B}">
-              <ma14:wrappingTextBoxFlag xmlns:ma14="http://schemas.microsoft.com/office/mac/drawingml/2011/main" xmlns:a14="http://schemas.microsoft.com/office/drawing/2010/main" xmlns:m="http://schemas.openxmlformats.org/officeDocument/2006/math" xmlns="" val="1"/>
+              <ma14:wrappingTextBoxFlag xmlns="" xmlns:m="http://schemas.openxmlformats.org/officeDocument/2006/math" xmlns:a14="http://schemas.microsoft.com/office/drawing/2010/main" xmlns:ma14="http://schemas.microsoft.com/office/mac/drawingml/2011/main" val="1"/>
             </a:ext>
           </a:extLst>
         </p:spPr>
@@ -7669,7 +7669,7 @@
           </a:ln>
           <a:extLst>
             <a:ext uri="{C572A759-6A51-4108-AA02-DFA0A04FC94B}">
-              <ma14:wrappingTextBoxFlag xmlns:ma14="http://schemas.microsoft.com/office/mac/drawingml/2011/main" xmlns:a14="http://schemas.microsoft.com/office/drawing/2010/main" xmlns:m="http://schemas.openxmlformats.org/officeDocument/2006/math" xmlns="" val="1"/>
+              <ma14:wrappingTextBoxFlag xmlns="" xmlns:m="http://schemas.openxmlformats.org/officeDocument/2006/math" xmlns:a14="http://schemas.microsoft.com/office/drawing/2010/main" xmlns:ma14="http://schemas.microsoft.com/office/mac/drawingml/2011/main" val="1"/>
             </a:ext>
           </a:extLst>
         </p:spPr>
@@ -7709,7 +7709,7 @@
           </a:ln>
           <a:extLst>
             <a:ext uri="{C572A759-6A51-4108-AA02-DFA0A04FC94B}">
-              <ma14:wrappingTextBoxFlag xmlns:ma14="http://schemas.microsoft.com/office/mac/drawingml/2011/main" xmlns:a14="http://schemas.microsoft.com/office/drawing/2010/main" xmlns:m="http://schemas.openxmlformats.org/officeDocument/2006/math" xmlns="" val="1"/>
+              <ma14:wrappingTextBoxFlag xmlns="" xmlns:m="http://schemas.openxmlformats.org/officeDocument/2006/math" xmlns:a14="http://schemas.microsoft.com/office/drawing/2010/main" xmlns:ma14="http://schemas.microsoft.com/office/mac/drawingml/2011/main" val="1"/>
             </a:ext>
           </a:extLst>
         </p:spPr>
@@ -7808,7 +7808,7 @@
           </a:ln>
           <a:extLst>
             <a:ext uri="{C572A759-6A51-4108-AA02-DFA0A04FC94B}">
-              <ma14:wrappingTextBoxFlag xmlns:ma14="http://schemas.microsoft.com/office/mac/drawingml/2011/main" xmlns:a14="http://schemas.microsoft.com/office/drawing/2010/main" xmlns:m="http://schemas.openxmlformats.org/officeDocument/2006/math" xmlns="" val="1"/>
+              <ma14:wrappingTextBoxFlag xmlns="" xmlns:m="http://schemas.openxmlformats.org/officeDocument/2006/math" xmlns:a14="http://schemas.microsoft.com/office/drawing/2010/main" xmlns:ma14="http://schemas.microsoft.com/office/mac/drawingml/2011/main" val="1"/>
             </a:ext>
           </a:extLst>
         </p:spPr>
@@ -7875,7 +7875,7 @@
           </a:ln>
           <a:extLst>
             <a:ext uri="{C572A759-6A51-4108-AA02-DFA0A04FC94B}">
-              <ma14:wrappingTextBoxFlag xmlns:ma14="http://schemas.microsoft.com/office/mac/drawingml/2011/main" xmlns:a14="http://schemas.microsoft.com/office/drawing/2010/main" xmlns:m="http://schemas.openxmlformats.org/officeDocument/2006/math" xmlns="" val="1"/>
+              <ma14:wrappingTextBoxFlag xmlns="" xmlns:m="http://schemas.openxmlformats.org/officeDocument/2006/math" xmlns:a14="http://schemas.microsoft.com/office/drawing/2010/main" xmlns:ma14="http://schemas.microsoft.com/office/mac/drawingml/2011/main" val="1"/>
             </a:ext>
           </a:extLst>
         </p:spPr>
@@ -7911,7 +7911,7 @@
           </a:ln>
           <a:extLst>
             <a:ext uri="{C572A759-6A51-4108-AA02-DFA0A04FC94B}">
-              <ma14:wrappingTextBoxFlag xmlns:ma14="http://schemas.microsoft.com/office/mac/drawingml/2011/main" xmlns:a14="http://schemas.microsoft.com/office/drawing/2010/main" xmlns:m="http://schemas.openxmlformats.org/officeDocument/2006/math" xmlns="" val="1"/>
+              <ma14:wrappingTextBoxFlag xmlns="" xmlns:m="http://schemas.openxmlformats.org/officeDocument/2006/math" xmlns:a14="http://schemas.microsoft.com/office/drawing/2010/main" xmlns:ma14="http://schemas.microsoft.com/office/mac/drawingml/2011/main" val="1"/>
             </a:ext>
           </a:extLst>
         </p:spPr>
@@ -7951,7 +7951,7 @@
           </a:ln>
           <a:extLst>
             <a:ext uri="{C572A759-6A51-4108-AA02-DFA0A04FC94B}">
-              <ma14:wrappingTextBoxFlag xmlns:ma14="http://schemas.microsoft.com/office/mac/drawingml/2011/main" xmlns:a14="http://schemas.microsoft.com/office/drawing/2010/main" xmlns:m="http://schemas.openxmlformats.org/officeDocument/2006/math" xmlns="" val="1"/>
+              <ma14:wrappingTextBoxFlag xmlns="" xmlns:m="http://schemas.openxmlformats.org/officeDocument/2006/math" xmlns:a14="http://schemas.microsoft.com/office/drawing/2010/main" xmlns:ma14="http://schemas.microsoft.com/office/mac/drawingml/2011/main" val="1"/>
             </a:ext>
           </a:extLst>
         </p:spPr>
@@ -8074,7 +8074,7 @@
           </a:ln>
           <a:extLst>
             <a:ext uri="{C572A759-6A51-4108-AA02-DFA0A04FC94B}">
-              <ma14:wrappingTextBoxFlag xmlns:ma14="http://schemas.microsoft.com/office/mac/drawingml/2011/main" xmlns:a14="http://schemas.microsoft.com/office/drawing/2010/main" xmlns:m="http://schemas.openxmlformats.org/officeDocument/2006/math" xmlns="" val="1"/>
+              <ma14:wrappingTextBoxFlag xmlns="" xmlns:m="http://schemas.openxmlformats.org/officeDocument/2006/math" xmlns:a14="http://schemas.microsoft.com/office/drawing/2010/main" xmlns:ma14="http://schemas.microsoft.com/office/mac/drawingml/2011/main" val="1"/>
             </a:ext>
           </a:extLst>
         </p:spPr>
@@ -8141,7 +8141,7 @@
           </a:ln>
           <a:extLst>
             <a:ext uri="{C572A759-6A51-4108-AA02-DFA0A04FC94B}">
-              <ma14:wrappingTextBoxFlag xmlns:ma14="http://schemas.microsoft.com/office/mac/drawingml/2011/main" xmlns:a14="http://schemas.microsoft.com/office/drawing/2010/main" xmlns:m="http://schemas.openxmlformats.org/officeDocument/2006/math" xmlns="" val="1"/>
+              <ma14:wrappingTextBoxFlag xmlns="" xmlns:m="http://schemas.openxmlformats.org/officeDocument/2006/math" xmlns:a14="http://schemas.microsoft.com/office/drawing/2010/main" xmlns:ma14="http://schemas.microsoft.com/office/mac/drawingml/2011/main" val="1"/>
             </a:ext>
           </a:extLst>
         </p:spPr>
@@ -8289,7 +8289,7 @@
           </a:ln>
           <a:extLst>
             <a:ext uri="{C572A759-6A51-4108-AA02-DFA0A04FC94B}">
-              <ma14:wrappingTextBoxFlag xmlns:ma14="http://schemas.microsoft.com/office/mac/drawingml/2011/main" xmlns:a14="http://schemas.microsoft.com/office/drawing/2010/main" xmlns:m="http://schemas.openxmlformats.org/officeDocument/2006/math" xmlns="" val="1"/>
+              <ma14:wrappingTextBoxFlag xmlns="" xmlns:m="http://schemas.openxmlformats.org/officeDocument/2006/math" xmlns:a14="http://schemas.microsoft.com/office/drawing/2010/main" xmlns:ma14="http://schemas.microsoft.com/office/mac/drawingml/2011/main" val="1"/>
             </a:ext>
           </a:extLst>
         </p:spPr>
@@ -8329,7 +8329,7 @@
           </a:ln>
           <a:extLst>
             <a:ext uri="{C572A759-6A51-4108-AA02-DFA0A04FC94B}">
-              <ma14:wrappingTextBoxFlag xmlns:ma14="http://schemas.microsoft.com/office/mac/drawingml/2011/main" xmlns:a14="http://schemas.microsoft.com/office/drawing/2010/main" xmlns:m="http://schemas.openxmlformats.org/officeDocument/2006/math" xmlns="" val="1"/>
+              <ma14:wrappingTextBoxFlag xmlns="" xmlns:m="http://schemas.openxmlformats.org/officeDocument/2006/math" xmlns:a14="http://schemas.microsoft.com/office/drawing/2010/main" xmlns:ma14="http://schemas.microsoft.com/office/mac/drawingml/2011/main" val="1"/>
             </a:ext>
           </a:extLst>
         </p:spPr>
@@ -8484,7 +8484,7 @@
           </a:ln>
           <a:extLst>
             <a:ext uri="{C572A759-6A51-4108-AA02-DFA0A04FC94B}">
-              <ma14:wrappingTextBoxFlag xmlns:ma14="http://schemas.microsoft.com/office/mac/drawingml/2011/main" xmlns:a14="http://schemas.microsoft.com/office/drawing/2010/main" xmlns:m="http://schemas.openxmlformats.org/officeDocument/2006/math" xmlns="" val="1"/>
+              <ma14:wrappingTextBoxFlag xmlns="" xmlns:m="http://schemas.openxmlformats.org/officeDocument/2006/math" xmlns:a14="http://schemas.microsoft.com/office/drawing/2010/main" xmlns:ma14="http://schemas.microsoft.com/office/mac/drawingml/2011/main" val="1"/>
             </a:ext>
           </a:extLst>
         </p:spPr>
@@ -8524,7 +8524,7 @@
           </a:ln>
           <a:extLst>
             <a:ext uri="{C572A759-6A51-4108-AA02-DFA0A04FC94B}">
-              <ma14:wrappingTextBoxFlag xmlns:ma14="http://schemas.microsoft.com/office/mac/drawingml/2011/main" xmlns:a14="http://schemas.microsoft.com/office/drawing/2010/main" xmlns:m="http://schemas.openxmlformats.org/officeDocument/2006/math" xmlns="" val="1"/>
+              <ma14:wrappingTextBoxFlag xmlns="" xmlns:m="http://schemas.openxmlformats.org/officeDocument/2006/math" xmlns:a14="http://schemas.microsoft.com/office/drawing/2010/main" xmlns:ma14="http://schemas.microsoft.com/office/mac/drawingml/2011/main" val="1"/>
             </a:ext>
           </a:extLst>
         </p:spPr>
@@ -8560,7 +8560,7 @@
           </a:ln>
           <a:extLst>
             <a:ext uri="{C572A759-6A51-4108-AA02-DFA0A04FC94B}">
-              <ma14:wrappingTextBoxFlag xmlns:ma14="http://schemas.microsoft.com/office/mac/drawingml/2011/main" xmlns:a14="http://schemas.microsoft.com/office/drawing/2010/main" xmlns:m="http://schemas.openxmlformats.org/officeDocument/2006/math" xmlns="" val="1"/>
+              <ma14:wrappingTextBoxFlag xmlns="" xmlns:m="http://schemas.openxmlformats.org/officeDocument/2006/math" xmlns:a14="http://schemas.microsoft.com/office/drawing/2010/main" xmlns:ma14="http://schemas.microsoft.com/office/mac/drawingml/2011/main" val="1"/>
             </a:ext>
           </a:extLst>
         </p:spPr>
@@ -8600,7 +8600,7 @@
           </a:ln>
           <a:extLst>
             <a:ext uri="{C572A759-6A51-4108-AA02-DFA0A04FC94B}">
-              <ma14:wrappingTextBoxFlag xmlns:ma14="http://schemas.microsoft.com/office/mac/drawingml/2011/main" xmlns:a14="http://schemas.microsoft.com/office/drawing/2010/main" xmlns:m="http://schemas.openxmlformats.org/officeDocument/2006/math" xmlns="" val="1"/>
+              <ma14:wrappingTextBoxFlag xmlns="" xmlns:m="http://schemas.openxmlformats.org/officeDocument/2006/math" xmlns:a14="http://schemas.microsoft.com/office/drawing/2010/main" xmlns:ma14="http://schemas.microsoft.com/office/mac/drawingml/2011/main" val="1"/>
             </a:ext>
           </a:extLst>
         </p:spPr>
@@ -8652,7 +8652,7 @@
           </a:ln>
           <a:extLst>
             <a:ext uri="{C572A759-6A51-4108-AA02-DFA0A04FC94B}">
-              <ma14:wrappingTextBoxFlag xmlns:ma14="http://schemas.microsoft.com/office/mac/drawingml/2011/main" xmlns:a14="http://schemas.microsoft.com/office/drawing/2010/main" xmlns:m="http://schemas.openxmlformats.org/officeDocument/2006/math" xmlns="" val="1"/>
+              <ma14:wrappingTextBoxFlag xmlns="" xmlns:m="http://schemas.openxmlformats.org/officeDocument/2006/math" xmlns:a14="http://schemas.microsoft.com/office/drawing/2010/main" xmlns:ma14="http://schemas.microsoft.com/office/mac/drawingml/2011/main" val="1"/>
             </a:ext>
           </a:extLst>
         </p:spPr>
@@ -8708,7 +8708,7 @@
           </a:ln>
           <a:extLst>
             <a:ext uri="{C572A759-6A51-4108-AA02-DFA0A04FC94B}">
-              <ma14:wrappingTextBoxFlag xmlns:ma14="http://schemas.microsoft.com/office/mac/drawingml/2011/main" xmlns:a14="http://schemas.microsoft.com/office/drawing/2010/main" xmlns:m="http://schemas.openxmlformats.org/officeDocument/2006/math" xmlns="" val="1"/>
+              <ma14:wrappingTextBoxFlag xmlns="" xmlns:m="http://schemas.openxmlformats.org/officeDocument/2006/math" xmlns:a14="http://schemas.microsoft.com/office/drawing/2010/main" xmlns:ma14="http://schemas.microsoft.com/office/mac/drawingml/2011/main" val="1"/>
             </a:ext>
           </a:extLst>
         </p:spPr>
@@ -8749,7 +8749,7 @@
           </a:ln>
           <a:extLst>
             <a:ext uri="{C572A759-6A51-4108-AA02-DFA0A04FC94B}">
-              <ma14:wrappingTextBoxFlag xmlns:ma14="http://schemas.microsoft.com/office/mac/drawingml/2011/main" xmlns:a14="http://schemas.microsoft.com/office/drawing/2010/main" xmlns:m="http://schemas.openxmlformats.org/officeDocument/2006/math" xmlns="" val="1"/>
+              <ma14:wrappingTextBoxFlag xmlns="" xmlns:m="http://schemas.openxmlformats.org/officeDocument/2006/math" xmlns:a14="http://schemas.microsoft.com/office/drawing/2010/main" xmlns:ma14="http://schemas.microsoft.com/office/mac/drawingml/2011/main" val="1"/>
             </a:ext>
           </a:extLst>
         </p:spPr>
@@ -8821,7 +8821,7 @@
           </a:ln>
           <a:extLst>
             <a:ext uri="{C572A759-6A51-4108-AA02-DFA0A04FC94B}">
-              <ma14:wrappingTextBoxFlag xmlns:ma14="http://schemas.microsoft.com/office/mac/drawingml/2011/main" xmlns:a14="http://schemas.microsoft.com/office/drawing/2010/main" xmlns:m="http://schemas.openxmlformats.org/officeDocument/2006/math" xmlns="" val="1"/>
+              <ma14:wrappingTextBoxFlag xmlns="" xmlns:m="http://schemas.openxmlformats.org/officeDocument/2006/math" xmlns:a14="http://schemas.microsoft.com/office/drawing/2010/main" xmlns:ma14="http://schemas.microsoft.com/office/mac/drawingml/2011/main" val="1"/>
             </a:ext>
           </a:extLst>
         </p:spPr>
@@ -8866,7 +8866,7 @@
           </a:ln>
           <a:extLst>
             <a:ext uri="{C572A759-6A51-4108-AA02-DFA0A04FC94B}">
-              <ma14:wrappingTextBoxFlag xmlns:ma14="http://schemas.microsoft.com/office/mac/drawingml/2011/main" xmlns:a14="http://schemas.microsoft.com/office/drawing/2010/main" xmlns:m="http://schemas.openxmlformats.org/officeDocument/2006/math" xmlns="" val="1"/>
+              <ma14:wrappingTextBoxFlag xmlns="" xmlns:m="http://schemas.openxmlformats.org/officeDocument/2006/math" xmlns:a14="http://schemas.microsoft.com/office/drawing/2010/main" xmlns:ma14="http://schemas.microsoft.com/office/mac/drawingml/2011/main" val="1"/>
             </a:ext>
           </a:extLst>
         </p:spPr>
@@ -8906,7 +8906,7 @@
           </a:ln>
           <a:extLst>
             <a:ext uri="{C572A759-6A51-4108-AA02-DFA0A04FC94B}">
-              <ma14:wrappingTextBoxFlag xmlns:ma14="http://schemas.microsoft.com/office/mac/drawingml/2011/main" xmlns:a14="http://schemas.microsoft.com/office/drawing/2010/main" xmlns:m="http://schemas.openxmlformats.org/officeDocument/2006/math" xmlns="" val="1"/>
+              <ma14:wrappingTextBoxFlag xmlns="" xmlns:m="http://schemas.openxmlformats.org/officeDocument/2006/math" xmlns:a14="http://schemas.microsoft.com/office/drawing/2010/main" xmlns:ma14="http://schemas.microsoft.com/office/mac/drawingml/2011/main" val="1"/>
             </a:ext>
           </a:extLst>
         </p:spPr>
@@ -8946,7 +8946,7 @@
           </a:ln>
           <a:extLst>
             <a:ext uri="{C572A759-6A51-4108-AA02-DFA0A04FC94B}">
-              <ma14:wrappingTextBoxFlag xmlns:ma14="http://schemas.microsoft.com/office/mac/drawingml/2011/main" xmlns:a14="http://schemas.microsoft.com/office/drawing/2010/main" xmlns:m="http://schemas.openxmlformats.org/officeDocument/2006/math" xmlns="" val="1"/>
+              <ma14:wrappingTextBoxFlag xmlns="" xmlns:m="http://schemas.openxmlformats.org/officeDocument/2006/math" xmlns:a14="http://schemas.microsoft.com/office/drawing/2010/main" xmlns:ma14="http://schemas.microsoft.com/office/mac/drawingml/2011/main" val="1"/>
             </a:ext>
           </a:extLst>
         </p:spPr>
@@ -8986,7 +8986,7 @@
           </a:ln>
           <a:extLst>
             <a:ext uri="{C572A759-6A51-4108-AA02-DFA0A04FC94B}">
-              <ma14:wrappingTextBoxFlag xmlns:ma14="http://schemas.microsoft.com/office/mac/drawingml/2011/main" xmlns:a14="http://schemas.microsoft.com/office/drawing/2010/main" xmlns:m="http://schemas.openxmlformats.org/officeDocument/2006/math" xmlns="" val="1"/>
+              <ma14:wrappingTextBoxFlag xmlns="" xmlns:m="http://schemas.openxmlformats.org/officeDocument/2006/math" xmlns:a14="http://schemas.microsoft.com/office/drawing/2010/main" xmlns:ma14="http://schemas.microsoft.com/office/mac/drawingml/2011/main" val="1"/>
             </a:ext>
           </a:extLst>
         </p:spPr>
@@ -9026,7 +9026,7 @@
           </a:ln>
           <a:extLst>
             <a:ext uri="{C572A759-6A51-4108-AA02-DFA0A04FC94B}">
-              <ma14:wrappingTextBoxFlag xmlns:ma14="http://schemas.microsoft.com/office/mac/drawingml/2011/main" xmlns:a14="http://schemas.microsoft.com/office/drawing/2010/main" xmlns:m="http://schemas.openxmlformats.org/officeDocument/2006/math" xmlns="" val="1"/>
+              <ma14:wrappingTextBoxFlag xmlns="" xmlns:m="http://schemas.openxmlformats.org/officeDocument/2006/math" xmlns:a14="http://schemas.microsoft.com/office/drawing/2010/main" xmlns:ma14="http://schemas.microsoft.com/office/mac/drawingml/2011/main" val="1"/>
             </a:ext>
           </a:extLst>
         </p:spPr>
@@ -9082,7 +9082,7 @@
           </a:ln>
           <a:extLst>
             <a:ext uri="{C572A759-6A51-4108-AA02-DFA0A04FC94B}">
-              <ma14:wrappingTextBoxFlag xmlns:ma14="http://schemas.microsoft.com/office/mac/drawingml/2011/main" xmlns:a14="http://schemas.microsoft.com/office/drawing/2010/main" xmlns:m="http://schemas.openxmlformats.org/officeDocument/2006/math" xmlns="" val="1"/>
+              <ma14:wrappingTextBoxFlag xmlns="" xmlns:m="http://schemas.openxmlformats.org/officeDocument/2006/math" xmlns:a14="http://schemas.microsoft.com/office/drawing/2010/main" xmlns:ma14="http://schemas.microsoft.com/office/mac/drawingml/2011/main" val="1"/>
             </a:ext>
           </a:extLst>
         </p:spPr>
@@ -9122,7 +9122,7 @@
           </a:ln>
           <a:extLst>
             <a:ext uri="{C572A759-6A51-4108-AA02-DFA0A04FC94B}">
-              <ma14:wrappingTextBoxFlag xmlns:ma14="http://schemas.microsoft.com/office/mac/drawingml/2011/main" xmlns:a14="http://schemas.microsoft.com/office/drawing/2010/main" xmlns:m="http://schemas.openxmlformats.org/officeDocument/2006/math" xmlns="" val="1"/>
+              <ma14:wrappingTextBoxFlag xmlns="" xmlns:m="http://schemas.openxmlformats.org/officeDocument/2006/math" xmlns:a14="http://schemas.microsoft.com/office/drawing/2010/main" xmlns:ma14="http://schemas.microsoft.com/office/mac/drawingml/2011/main" val="1"/>
             </a:ext>
           </a:extLst>
         </p:spPr>
@@ -9166,7 +9166,7 @@
           </a:ln>
           <a:extLst>
             <a:ext uri="{C572A759-6A51-4108-AA02-DFA0A04FC94B}">
-              <ma14:wrappingTextBoxFlag xmlns:ma14="http://schemas.microsoft.com/office/mac/drawingml/2011/main" xmlns:a14="http://schemas.microsoft.com/office/drawing/2010/main" xmlns:m="http://schemas.openxmlformats.org/officeDocument/2006/math" xmlns="" val="1"/>
+              <ma14:wrappingTextBoxFlag xmlns="" xmlns:m="http://schemas.openxmlformats.org/officeDocument/2006/math" xmlns:a14="http://schemas.microsoft.com/office/drawing/2010/main" xmlns:ma14="http://schemas.microsoft.com/office/mac/drawingml/2011/main" val="1"/>
             </a:ext>
           </a:extLst>
         </p:spPr>
@@ -9206,7 +9206,7 @@
           </a:ln>
           <a:extLst>
             <a:ext uri="{C572A759-6A51-4108-AA02-DFA0A04FC94B}">
-              <ma14:wrappingTextBoxFlag xmlns:ma14="http://schemas.microsoft.com/office/mac/drawingml/2011/main" xmlns:a14="http://schemas.microsoft.com/office/drawing/2010/main" xmlns:m="http://schemas.openxmlformats.org/officeDocument/2006/math" xmlns="" val="1"/>
+              <ma14:wrappingTextBoxFlag xmlns="" xmlns:m="http://schemas.openxmlformats.org/officeDocument/2006/math" xmlns:a14="http://schemas.microsoft.com/office/drawing/2010/main" xmlns:ma14="http://schemas.microsoft.com/office/mac/drawingml/2011/main" val="1"/>
             </a:ext>
           </a:extLst>
         </p:spPr>
@@ -9246,7 +9246,7 @@
           </a:ln>
           <a:extLst>
             <a:ext uri="{C572A759-6A51-4108-AA02-DFA0A04FC94B}">
-              <ma14:wrappingTextBoxFlag xmlns:ma14="http://schemas.microsoft.com/office/mac/drawingml/2011/main" xmlns:a14="http://schemas.microsoft.com/office/drawing/2010/main" xmlns:m="http://schemas.openxmlformats.org/officeDocument/2006/math" xmlns="" val="1"/>
+              <ma14:wrappingTextBoxFlag xmlns="" xmlns:m="http://schemas.openxmlformats.org/officeDocument/2006/math" xmlns:a14="http://schemas.microsoft.com/office/drawing/2010/main" xmlns:ma14="http://schemas.microsoft.com/office/mac/drawingml/2011/main" val="1"/>
             </a:ext>
           </a:extLst>
         </p:spPr>
@@ -9323,7 +9323,7 @@
           </a:ln>
           <a:extLst>
             <a:ext uri="{C572A759-6A51-4108-AA02-DFA0A04FC94B}">
-              <ma14:wrappingTextBoxFlag xmlns="" xmlns:m="http://schemas.openxmlformats.org/officeDocument/2006/math" xmlns:a14="http://schemas.microsoft.com/office/drawing/2010/main" xmlns:ma14="http://schemas.microsoft.com/office/mac/drawingml/2011/main" val="1"/>
+              <ma14:wrappingTextBoxFlag xmlns:ma14="http://schemas.microsoft.com/office/mac/drawingml/2011/main" xmlns:a14="http://schemas.microsoft.com/office/drawing/2010/main" xmlns:m="http://schemas.openxmlformats.org/officeDocument/2006/math" xmlns="" val="1"/>
             </a:ext>
           </a:extLst>
         </p:spPr>
@@ -9369,7 +9369,7 @@
           </a:ln>
           <a:extLst>
             <a:ext uri="{C572A759-6A51-4108-AA02-DFA0A04FC94B}">
-              <ma14:wrappingTextBoxFlag xmlns="" xmlns:m="http://schemas.openxmlformats.org/officeDocument/2006/math" xmlns:a14="http://schemas.microsoft.com/office/drawing/2010/main" xmlns:ma14="http://schemas.microsoft.com/office/mac/drawingml/2011/main" val="1"/>
+              <ma14:wrappingTextBoxFlag xmlns:ma14="http://schemas.microsoft.com/office/mac/drawingml/2011/main" xmlns:a14="http://schemas.microsoft.com/office/drawing/2010/main" xmlns:m="http://schemas.openxmlformats.org/officeDocument/2006/math" xmlns="" val="1"/>
             </a:ext>
           </a:extLst>
         </p:spPr>
@@ -9613,7 +9613,7 @@
           </a:ln>
           <a:extLst>
             <a:ext uri="{C572A759-6A51-4108-AA02-DFA0A04FC94B}">
-              <ma14:wrappingTextBoxFlag xmlns:ma14="http://schemas.microsoft.com/office/mac/drawingml/2011/main" xmlns:a14="http://schemas.microsoft.com/office/drawing/2010/main" xmlns:m="http://schemas.openxmlformats.org/officeDocument/2006/math" xmlns="" val="1"/>
+              <ma14:wrappingTextBoxFlag xmlns="" xmlns:m="http://schemas.openxmlformats.org/officeDocument/2006/math" xmlns:a14="http://schemas.microsoft.com/office/drawing/2010/main" xmlns:ma14="http://schemas.microsoft.com/office/mac/drawingml/2011/main" val="1"/>
             </a:ext>
           </a:extLst>
         </p:spPr>
@@ -9653,7 +9653,7 @@
           </a:ln>
           <a:extLst>
             <a:ext uri="{C572A759-6A51-4108-AA02-DFA0A04FC94B}">
-              <ma14:wrappingTextBoxFlag xmlns:ma14="http://schemas.microsoft.com/office/mac/drawingml/2011/main" xmlns:a14="http://schemas.microsoft.com/office/drawing/2010/main" xmlns:m="http://schemas.openxmlformats.org/officeDocument/2006/math" xmlns="" val="1"/>
+              <ma14:wrappingTextBoxFlag xmlns="" xmlns:m="http://schemas.openxmlformats.org/officeDocument/2006/math" xmlns:a14="http://schemas.microsoft.com/office/drawing/2010/main" xmlns:ma14="http://schemas.microsoft.com/office/mac/drawingml/2011/main" val="1"/>
             </a:ext>
           </a:extLst>
         </p:spPr>
@@ -9760,7 +9760,7 @@
           </a:ln>
           <a:extLst>
             <a:ext uri="{C572A759-6A51-4108-AA02-DFA0A04FC94B}">
-              <ma14:wrappingTextBoxFlag xmlns:ma14="http://schemas.microsoft.com/office/mac/drawingml/2011/main" xmlns:a14="http://schemas.microsoft.com/office/drawing/2010/main" xmlns:m="http://schemas.openxmlformats.org/officeDocument/2006/math" xmlns="" val="1"/>
+              <ma14:wrappingTextBoxFlag xmlns="" xmlns:m="http://schemas.openxmlformats.org/officeDocument/2006/math" xmlns:a14="http://schemas.microsoft.com/office/drawing/2010/main" xmlns:ma14="http://schemas.microsoft.com/office/mac/drawingml/2011/main" val="1"/>
             </a:ext>
           </a:extLst>
         </p:spPr>
@@ -9833,7 +9833,7 @@
           </a:ln>
           <a:extLst>
             <a:ext uri="{C572A759-6A51-4108-AA02-DFA0A04FC94B}">
-              <ma14:wrappingTextBoxFlag xmlns:ma14="http://schemas.microsoft.com/office/mac/drawingml/2011/main" xmlns:a14="http://schemas.microsoft.com/office/drawing/2010/main" xmlns:m="http://schemas.openxmlformats.org/officeDocument/2006/math" xmlns="" val="1"/>
+              <ma14:wrappingTextBoxFlag xmlns="" xmlns:m="http://schemas.openxmlformats.org/officeDocument/2006/math" xmlns:a14="http://schemas.microsoft.com/office/drawing/2010/main" xmlns:ma14="http://schemas.microsoft.com/office/mac/drawingml/2011/main" val="1"/>
             </a:ext>
           </a:extLst>
         </p:spPr>
@@ -9879,7 +9879,7 @@
           </a:ln>
           <a:extLst>
             <a:ext uri="{C572A759-6A51-4108-AA02-DFA0A04FC94B}">
-              <ma14:wrappingTextBoxFlag xmlns:ma14="http://schemas.microsoft.com/office/mac/drawingml/2011/main" xmlns:a14="http://schemas.microsoft.com/office/drawing/2010/main" xmlns:m="http://schemas.openxmlformats.org/officeDocument/2006/math" xmlns="" val="1"/>
+              <ma14:wrappingTextBoxFlag xmlns="" xmlns:m="http://schemas.openxmlformats.org/officeDocument/2006/math" xmlns:a14="http://schemas.microsoft.com/office/drawing/2010/main" xmlns:ma14="http://schemas.microsoft.com/office/mac/drawingml/2011/main" val="1"/>
             </a:ext>
           </a:extLst>
         </p:spPr>
@@ -10145,7 +10145,7 @@
           </a:ln>
           <a:extLst>
             <a:ext uri="{C572A759-6A51-4108-AA02-DFA0A04FC94B}">
-              <ma14:wrappingTextBoxFlag xmlns:ma14="http://schemas.microsoft.com/office/mac/drawingml/2011/main" xmlns:a14="http://schemas.microsoft.com/office/drawing/2010/main" xmlns:m="http://schemas.openxmlformats.org/officeDocument/2006/math" xmlns="" val="1"/>
+              <ma14:wrappingTextBoxFlag xmlns="" xmlns:m="http://schemas.openxmlformats.org/officeDocument/2006/math" xmlns:a14="http://schemas.microsoft.com/office/drawing/2010/main" xmlns:ma14="http://schemas.microsoft.com/office/mac/drawingml/2011/main" val="1"/>
             </a:ext>
           </a:extLst>
         </p:spPr>
@@ -10193,14 +10193,14 @@
           <p:nvPr>
             <p:extLst>
               <p:ext uri="{D42A27DB-BD31-4B8C-83A1-F6EECF244321}">
-                <p14:modId xmlns:p14="http://schemas.microsoft.com/office/powerpoint/2010/main" val="1979347636"/>
+                <p14:modId xmlns:p14="http://schemas.microsoft.com/office/powerpoint/2010/main" val="3923356889"/>
               </p:ext>
             </p:extLst>
           </p:nvPr>
         </p:nvGraphicFramePr>
         <p:xfrm>
           <a:off x="966762" y="502853"/>
-          <a:ext cx="9671501" cy="6090712"/>
+          <a:ext cx="9671501" cy="5093146"/>
         </p:xfrm>
         <a:graphic>
           <a:graphicData uri="http://schemas.openxmlformats.org/drawingml/2006/table">
@@ -10559,12 +10559,21 @@
                     <a:bodyPr/>
                     <a:lstStyle/>
                     <a:p>
-                      <a:pPr marL="228600" indent="-228600" algn="l" defTabSz="2438338">
+                      <a:pPr marL="228600" marR="0" lvl="0" indent="-228600" algn="l" defTabSz="2438338" rtl="0" eaLnBrk="1" fontAlgn="auto" latinLnBrk="0" hangingPunct="1">
+                        <a:lnSpc>
+                          <a:spcPct val="100000"/>
+                        </a:lnSpc>
                         <a:spcBef>
                           <a:spcPts val="600"/>
                         </a:spcBef>
+                        <a:spcAft>
+                          <a:spcPts val="0"/>
+                        </a:spcAft>
+                        <a:buClrTx/>
                         <a:buSzPct val="100000"/>
+                        <a:buFontTx/>
                         <a:buChar char="•"/>
+                        <a:tabLst/>
                         <a:defRPr sz="3000">
                           <a:solidFill>
                             <a:srgbClr val="5E5E5E"/>
@@ -10577,9 +10586,8 @@
                       </a:pPr>
                       <a:r>
                         <a:rPr lang="en-US" sz="1400" dirty="0"/>
-                        <a:t>No class - Holiday</a:t>
+                        <a:t>RNA-seq analysis</a:t>
                       </a:r>
-                      <a:endParaRPr sz="1400" dirty="0"/>
                     </a:p>
                   </a:txBody>
                   <a:tcPr marL="23947" marR="23947" marT="23947" marB="23947" anchor="ctr" horzOverflow="overflow"/>
@@ -10604,124 +10612,7 @@
                       </a:pPr>
                       <a:r>
                         <a:rPr lang="en-US" sz="1500" b="1" dirty="0"/>
-                        <a:t>April 26</a:t>
-                      </a:r>
-                      <a:endParaRPr sz="1500" b="1" dirty="0"/>
-                    </a:p>
-                  </a:txBody>
-                  <a:tcPr marL="23947" marR="23947" marT="23947" marB="23947" anchor="ctr" horzOverflow="overflow"/>
-                </a:tc>
-                <a:tc>
-                  <a:txBody>
-                    <a:bodyPr/>
-                    <a:lstStyle/>
-                    <a:p>
-                      <a:pPr marL="228600" indent="-228600" algn="l" defTabSz="2438338">
-                        <a:spcBef>
-                          <a:spcPts val="600"/>
-                        </a:spcBef>
-                        <a:buSzPct val="100000"/>
-                        <a:buChar char="•"/>
-                        <a:defRPr sz="3000">
-                          <a:solidFill>
-                            <a:srgbClr val="5E5E5E"/>
-                          </a:solidFill>
-                          <a:latin typeface="Avenir Next Regular"/>
-                          <a:ea typeface="Avenir Next Regular"/>
-                          <a:cs typeface="Avenir Next Regular"/>
-                          <a:sym typeface="Avenir Next Regular"/>
-                        </a:defRPr>
-                      </a:pPr>
-                      <a:r>
-                        <a:rPr lang="en-US" sz="1400" dirty="0"/>
-                        <a:t>No Class</a:t>
-                      </a:r>
-                      <a:endParaRPr sz="1400" dirty="0"/>
-                    </a:p>
-                  </a:txBody>
-                  <a:tcPr marL="23947" marR="23947" marT="23947" marB="23947" anchor="ctr" horzOverflow="overflow"/>
-                </a:tc>
-                <a:extLst>
-                  <a:ext uri="{0D108BD9-81ED-4DB2-BD59-A6C34878D82A}">
-                    <a16:rowId xmlns:a16="http://schemas.microsoft.com/office/drawing/2014/main" val="3006099311"/>
-                  </a:ext>
-                </a:extLst>
-              </a:tr>
-              <a:tr h="428734">
-                <a:tc>
-                  <a:txBody>
-                    <a:bodyPr/>
-                    <a:lstStyle/>
-                    <a:p>
-                      <a:pPr defTabSz="914400">
-                        <a:tabLst>
-                          <a:tab pos="1663700" algn="l"/>
-                        </a:tabLst>
-                        <a:defRPr b="0"/>
-                      </a:pPr>
-                      <a:r>
-                        <a:rPr sz="1500" b="1" dirty="0"/>
-                        <a:t>April 2</a:t>
-                      </a:r>
-                      <a:r>
-                        <a:rPr lang="en-US" sz="1500" b="1" dirty="0"/>
-                        <a:t>9</a:t>
-                      </a:r>
-                      <a:endParaRPr sz="1500" b="1" dirty="0"/>
-                    </a:p>
-                  </a:txBody>
-                  <a:tcPr marL="23947" marR="23947" marT="23947" marB="23947" anchor="ctr" horzOverflow="overflow"/>
-                </a:tc>
-                <a:tc>
-                  <a:txBody>
-                    <a:bodyPr/>
-                    <a:lstStyle/>
-                    <a:p>
-                      <a:pPr marL="228600" indent="-228600" algn="l" defTabSz="2438338">
-                        <a:spcBef>
-                          <a:spcPts val="1000"/>
-                        </a:spcBef>
-                        <a:buSzPct val="100000"/>
-                        <a:buChar char="•"/>
-                        <a:defRPr sz="3000">
-                          <a:solidFill>
-                            <a:srgbClr val="5E5E5E"/>
-                          </a:solidFill>
-                          <a:latin typeface="Avenir Next Regular"/>
-                          <a:ea typeface="Avenir Next Regular"/>
-                          <a:cs typeface="Avenir Next Regular"/>
-                          <a:sym typeface="Avenir Next Regular"/>
-                        </a:defRPr>
-                      </a:pPr>
-                      <a:r>
-                        <a:rPr sz="1400"/>
-                        <a:t>RNA-seq analysis </a:t>
-                      </a:r>
-                    </a:p>
-                  </a:txBody>
-                  <a:tcPr marL="23947" marR="23947" marT="23947" marB="23947" anchor="ctr" horzOverflow="overflow"/>
-                </a:tc>
-                <a:extLst>
-                  <a:ext uri="{0D108BD9-81ED-4DB2-BD59-A6C34878D82A}">
-                    <a16:rowId xmlns:a16="http://schemas.microsoft.com/office/drawing/2014/main" val="10003"/>
-                  </a:ext>
-                </a:extLst>
-              </a:tr>
-              <a:tr h="598666">
-                <a:tc>
-                  <a:txBody>
-                    <a:bodyPr/>
-                    <a:lstStyle/>
-                    <a:p>
-                      <a:pPr defTabSz="914400">
-                        <a:tabLst>
-                          <a:tab pos="1663700" algn="l"/>
-                        </a:tabLst>
-                        <a:defRPr b="0"/>
-                      </a:pPr>
-                      <a:r>
-                        <a:rPr lang="en-US" sz="1500" b="1" dirty="0"/>
-                        <a:t>extra</a:t>
+                        <a:t>April 27</a:t>
                       </a:r>
                       <a:endParaRPr sz="1500" b="1" dirty="0"/>
                     </a:p>
@@ -10775,14 +10666,13 @@
                         <a:rPr lang="en-US" sz="1400" dirty="0"/>
                         <a:t>Batch Effects</a:t>
                       </a:r>
-                      <a:endParaRPr sz="1400" dirty="0"/>
                     </a:p>
                   </a:txBody>
                   <a:tcPr marL="23947" marR="23947" marT="23947" marB="23947" anchor="ctr" horzOverflow="overflow"/>
                 </a:tc>
                 <a:extLst>
                   <a:ext uri="{0D108BD9-81ED-4DB2-BD59-A6C34878D82A}">
-                    <a16:rowId xmlns:a16="http://schemas.microsoft.com/office/drawing/2014/main" val="10004"/>
+                    <a16:rowId xmlns:a16="http://schemas.microsoft.com/office/drawing/2014/main" val="3006099311"/>
                   </a:ext>
                 </a:extLst>
               </a:tr>
@@ -10800,7 +10690,7 @@
                       </a:pPr>
                       <a:r>
                         <a:rPr lang="en-US" sz="1500" b="1" dirty="0"/>
-                        <a:t>extra</a:t>
+                        <a:t>Extras</a:t>
                       </a:r>
                       <a:endParaRPr sz="1500" b="1" dirty="0"/>
                     </a:p>
@@ -10954,7 +10844,7 @@
           </a:ln>
           <a:extLst>
             <a:ext uri="{C572A759-6A51-4108-AA02-DFA0A04FC94B}">
-              <ma14:wrappingTextBoxFlag xmlns:ma14="http://schemas.microsoft.com/office/mac/drawingml/2011/main" xmlns:a14="http://schemas.microsoft.com/office/drawing/2010/main" xmlns:m="http://schemas.openxmlformats.org/officeDocument/2006/math" xmlns="" val="1"/>
+              <ma14:wrappingTextBoxFlag xmlns="" xmlns:m="http://schemas.openxmlformats.org/officeDocument/2006/math" xmlns:a14="http://schemas.microsoft.com/office/drawing/2010/main" xmlns:ma14="http://schemas.microsoft.com/office/mac/drawingml/2011/main" val="1"/>
             </a:ext>
           </a:extLst>
         </p:spPr>
@@ -11004,7 +10894,7 @@
           </a:ln>
           <a:extLst>
             <a:ext uri="{C572A759-6A51-4108-AA02-DFA0A04FC94B}">
-              <ma14:wrappingTextBoxFlag xmlns:ma14="http://schemas.microsoft.com/office/mac/drawingml/2011/main" xmlns:a14="http://schemas.microsoft.com/office/drawing/2010/main" xmlns:m="http://schemas.openxmlformats.org/officeDocument/2006/math" xmlns="" val="1"/>
+              <ma14:wrappingTextBoxFlag xmlns="" xmlns:m="http://schemas.openxmlformats.org/officeDocument/2006/math" xmlns:a14="http://schemas.microsoft.com/office/drawing/2010/main" xmlns:ma14="http://schemas.microsoft.com/office/mac/drawingml/2011/main" val="1"/>
             </a:ext>
           </a:extLst>
         </p:spPr>
@@ -11283,7 +11173,7 @@
           </a:ln>
           <a:extLst>
             <a:ext uri="{C572A759-6A51-4108-AA02-DFA0A04FC94B}">
-              <ma14:wrappingTextBoxFlag xmlns:ma14="http://schemas.microsoft.com/office/mac/drawingml/2011/main" xmlns:a14="http://schemas.microsoft.com/office/drawing/2010/main" xmlns:m="http://schemas.openxmlformats.org/officeDocument/2006/math" xmlns="" val="1"/>
+              <ma14:wrappingTextBoxFlag xmlns="" xmlns:m="http://schemas.openxmlformats.org/officeDocument/2006/math" xmlns:a14="http://schemas.microsoft.com/office/drawing/2010/main" xmlns:ma14="http://schemas.microsoft.com/office/mac/drawingml/2011/main" val="1"/>
             </a:ext>
           </a:extLst>
         </p:spPr>
@@ -11328,7 +11218,7 @@
           </a:ln>
           <a:extLst>
             <a:ext uri="{C572A759-6A51-4108-AA02-DFA0A04FC94B}">
-              <ma14:wrappingTextBoxFlag xmlns:ma14="http://schemas.microsoft.com/office/mac/drawingml/2011/main" xmlns:a14="http://schemas.microsoft.com/office/drawing/2010/main" xmlns:m="http://schemas.openxmlformats.org/officeDocument/2006/math" xmlns="" val="1"/>
+              <ma14:wrappingTextBoxFlag xmlns="" xmlns:m="http://schemas.openxmlformats.org/officeDocument/2006/math" xmlns:a14="http://schemas.microsoft.com/office/drawing/2010/main" xmlns:ma14="http://schemas.microsoft.com/office/mac/drawingml/2011/main" val="1"/>
             </a:ext>
           </a:extLst>
         </p:spPr>
@@ -11505,7 +11395,7 @@
           </a:ln>
           <a:extLst>
             <a:ext uri="{C572A759-6A51-4108-AA02-DFA0A04FC94B}">
-              <ma14:wrappingTextBoxFlag xmlns:ma14="http://schemas.microsoft.com/office/mac/drawingml/2011/main" xmlns:a14="http://schemas.microsoft.com/office/drawing/2010/main" xmlns:m="http://schemas.openxmlformats.org/officeDocument/2006/math" xmlns="" val="1"/>
+              <ma14:wrappingTextBoxFlag xmlns="" xmlns:m="http://schemas.openxmlformats.org/officeDocument/2006/math" xmlns:a14="http://schemas.microsoft.com/office/drawing/2010/main" xmlns:ma14="http://schemas.microsoft.com/office/mac/drawingml/2011/main" val="1"/>
             </a:ext>
           </a:extLst>
         </p:spPr>
@@ -11545,7 +11435,7 @@
           </a:ln>
           <a:extLst>
             <a:ext uri="{C572A759-6A51-4108-AA02-DFA0A04FC94B}">
-              <ma14:wrappingTextBoxFlag xmlns:ma14="http://schemas.microsoft.com/office/mac/drawingml/2011/main" xmlns:a14="http://schemas.microsoft.com/office/drawing/2010/main" xmlns:m="http://schemas.openxmlformats.org/officeDocument/2006/math" xmlns="" val="1"/>
+              <ma14:wrappingTextBoxFlag xmlns="" xmlns:m="http://schemas.openxmlformats.org/officeDocument/2006/math" xmlns:a14="http://schemas.microsoft.com/office/drawing/2010/main" xmlns:ma14="http://schemas.microsoft.com/office/mac/drawingml/2011/main" val="1"/>
             </a:ext>
           </a:extLst>
         </p:spPr>
@@ -11636,7 +11526,7 @@
           </a:ln>
           <a:extLst>
             <a:ext uri="{C572A759-6A51-4108-AA02-DFA0A04FC94B}">
-              <ma14:wrappingTextBoxFlag xmlns:ma14="http://schemas.microsoft.com/office/mac/drawingml/2011/main" xmlns:a14="http://schemas.microsoft.com/office/drawing/2010/main" xmlns:m="http://schemas.openxmlformats.org/officeDocument/2006/math" xmlns="" val="1"/>
+              <ma14:wrappingTextBoxFlag xmlns="" xmlns:m="http://schemas.openxmlformats.org/officeDocument/2006/math" xmlns:a14="http://schemas.microsoft.com/office/drawing/2010/main" xmlns:ma14="http://schemas.microsoft.com/office/mac/drawingml/2011/main" val="1"/>
             </a:ext>
           </a:extLst>
         </p:spPr>
@@ -11685,7 +11575,7 @@
           </a:ln>
           <a:extLst>
             <a:ext uri="{C572A759-6A51-4108-AA02-DFA0A04FC94B}">
-              <ma14:wrappingTextBoxFlag xmlns:ma14="http://schemas.microsoft.com/office/mac/drawingml/2011/main" xmlns:a14="http://schemas.microsoft.com/office/drawing/2010/main" xmlns:m="http://schemas.openxmlformats.org/officeDocument/2006/math" xmlns="" val="1"/>
+              <ma14:wrappingTextBoxFlag xmlns="" xmlns:m="http://schemas.openxmlformats.org/officeDocument/2006/math" xmlns:a14="http://schemas.microsoft.com/office/drawing/2010/main" xmlns:ma14="http://schemas.microsoft.com/office/mac/drawingml/2011/main" val="1"/>
             </a:ext>
           </a:extLst>
         </p:spPr>
@@ -11839,7 +11729,7 @@
           </a:ln>
           <a:extLst>
             <a:ext uri="{C572A759-6A51-4108-AA02-DFA0A04FC94B}">
-              <ma14:wrappingTextBoxFlag xmlns:ma14="http://schemas.microsoft.com/office/mac/drawingml/2011/main" xmlns:a14="http://schemas.microsoft.com/office/drawing/2010/main" xmlns:m="http://schemas.openxmlformats.org/officeDocument/2006/math" xmlns="" val="1"/>
+              <ma14:wrappingTextBoxFlag xmlns="" xmlns:m="http://schemas.openxmlformats.org/officeDocument/2006/math" xmlns:a14="http://schemas.microsoft.com/office/drawing/2010/main" xmlns:ma14="http://schemas.microsoft.com/office/mac/drawingml/2011/main" val="1"/>
             </a:ext>
           </a:extLst>
         </p:spPr>
@@ -11879,7 +11769,7 @@
           </a:ln>
           <a:extLst>
             <a:ext uri="{C572A759-6A51-4108-AA02-DFA0A04FC94B}">
-              <ma14:wrappingTextBoxFlag xmlns:ma14="http://schemas.microsoft.com/office/mac/drawingml/2011/main" xmlns:a14="http://schemas.microsoft.com/office/drawing/2010/main" xmlns:m="http://schemas.openxmlformats.org/officeDocument/2006/math" xmlns="" val="1"/>
+              <ma14:wrappingTextBoxFlag xmlns="" xmlns:m="http://schemas.openxmlformats.org/officeDocument/2006/math" xmlns:a14="http://schemas.microsoft.com/office/drawing/2010/main" xmlns:ma14="http://schemas.microsoft.com/office/mac/drawingml/2011/main" val="1"/>
             </a:ext>
           </a:extLst>
         </p:spPr>
@@ -11946,7 +11836,7 @@
           </a:ln>
           <a:extLst>
             <a:ext uri="{C572A759-6A51-4108-AA02-DFA0A04FC94B}">
-              <ma14:wrappingTextBoxFlag xmlns:ma14="http://schemas.microsoft.com/office/mac/drawingml/2011/main" xmlns:a14="http://schemas.microsoft.com/office/drawing/2010/main" xmlns:m="http://schemas.openxmlformats.org/officeDocument/2006/math" xmlns="" val="1"/>
+              <ma14:wrappingTextBoxFlag xmlns="" xmlns:m="http://schemas.openxmlformats.org/officeDocument/2006/math" xmlns:a14="http://schemas.microsoft.com/office/drawing/2010/main" xmlns:ma14="http://schemas.microsoft.com/office/mac/drawingml/2011/main" val="1"/>
             </a:ext>
           </a:extLst>
         </p:spPr>

</xml_diff>